<commit_message>
Presentation: fix the deck so PowerPoint opens it
PowerPoint rejected the file as corrupt (LibreOffice and the validator
accepted it). Cause: paragraphs mixing runs got a second <a:pPr> mid-
paragraph, and shape id 25 was reused on most slides. The cover's info
block is now one text box per line, and a post-build step keeps one pPr
per paragraph and renumbers shape ids. Verified by opening the file in
PowerPoint 16 (12 slides) and exporting slides from it.

Co-Authored-By: Claude Opus 5.5 <noreply@anthropic.com>
Claude-Session: https://claude.ai/code/session_01R2t3DQ3WiMBbtueYMbxJvA
</commit_message>
<xml_diff>
--- a/docs/EchoFlow_Hackathon_Submission.pptx
+++ b/docs/EchoFlow_Hackathon_Submission.pptx
@@ -118,31 +118,31 @@
   <p:extLst>
     <p:ext uri="{521415D9-36F7-43E2-AB2F-B90AF26B5E84}">
       <p14:sectionLst xmlns:p14="http://schemas.microsoft.com/office/powerpoint/2010/main">
-        <p14:section name="Cover" id="{cb20f616-fb00-6837-ea55-dcc1d1f556b0}">
+        <p14:section name="Cover" id="{024301d0-2d4c-2ec3-2c42-5d28aca111a9}">
           <p14:sldIdLst>
             <p14:sldId id="256"/>
           </p14:sldIdLst>
         </p14:section>
-        <p14:section name="Problem and solution" id="{d6b8cf3c-3197-d1ed-5136-e5a058db1a82}">
+        <p14:section name="Problem and solution" id="{64bb3b0d-5135-fc35-a0bb-ab204d61f186}">
           <p14:sldIdLst>
             <p14:sldId id="257"/>
             <p14:sldId id="258"/>
           </p14:sldIdLst>
         </p14:section>
-        <p14:section name="How it works" id="{f59c5c97-8a21-801f-a7ed-cf2b0c9ce7d5}">
+        <p14:section name="How it works" id="{d59c99bc-a099-50ad-3070-731da70a9413}">
           <p14:sldIdLst>
             <p14:sldId id="259"/>
             <p14:sldId id="260"/>
             <p14:sldId id="261"/>
           </p14:sldIdLst>
         </p14:section>
-        <p14:section name="Impact and results" id="{6d79be53-fc52-fde3-84dd-fab4a5fb19d6}">
+        <p14:section name="Impact and results" id="{614b0292-d7e9-95bf-20ff-11ff9c9b74a5}">
           <p14:sldIdLst>
             <p14:sldId id="262"/>
             <p14:sldId id="263"/>
           </p14:sldIdLst>
         </p14:section>
-        <p14:section name="Next and wrap-up" id="{880ba9c3-6396-5d7b-d0e8-15102d8b7dfc}">
+        <p14:section name="Next and wrap-up" id="{ffc129c9-ca88-4bc3-b907-bbd16e73258c}">
           <p14:sldIdLst>
             <p14:sldId id="264"/>
             <p14:sldId id="265"/>
@@ -1695,7 +1695,7 @@
       </p:sp>
       <p:sp>
         <p:nvSpPr>
-          <p:cNvPr id="25" name="Slide Number Placeholder 0"/>
+          <p:cNvPr id="4" name="Slide Number Placeholder 0"/>
           <p:cNvSpPr>
             <a:spLocks noGrp="1"/>
           </p:cNvSpPr>
@@ -1797,7 +1797,7 @@
       </p:grpSpPr>
       <p:sp>
         <p:nvSpPr>
-          <p:cNvPr id="25" name="Slide Number Placeholder 0"/>
+          <p:cNvPr id="2" name="Slide Number Placeholder 0"/>
           <p:cNvSpPr>
             <a:spLocks noGrp="1"/>
           </p:cNvSpPr>
@@ -2286,9 +2286,6 @@
               </a:rPr>
               <a:t>3rd Edition</a:t>
             </a:r>
-            <a:pPr indent="0" marL="0">
-              <a:buNone/>
-            </a:pPr>
             <a:r>
               <a:rPr lang="en-US" sz="1600" dirty="0">
                 <a:solidFill>
@@ -2484,7 +2481,7 @@
         <p:spPr>
           <a:xfrm>
             <a:off x="777240" y="4343400"/>
-            <a:ext cx="6309360" cy="1737360"/>
+            <a:ext cx="914400" cy="274320"/>
           </a:xfrm>
           <a:prstGeom prst="rect">
             <a:avLst/>
@@ -2497,9 +2494,6 @@
           <a:lstStyle/>
           <a:p>
             <a:pPr indent="0" marL="0">
-              <a:spcAft>
-                <a:spcPts val="400"/>
-              </a:spcAft>
               <a:buNone/>
             </a:pPr>
             <a:r>
@@ -2508,12 +2502,34 @@
                   <a:schemeClr val="accent1"/>
                 </a:solidFill>
               </a:rPr>
-              <a:t>Theme ID   </a:t>
-            </a:r>
+              <a:t>Theme ID</a:t>
+            </a:r>
+            <a:endParaRPr lang="en-US" sz="1150" dirty="0"/>
+          </a:p>
+        </p:txBody>
+      </p:sp>
+      <p:sp>
+        <p:nvSpPr>
+          <p:cNvPr id="14" name="Text 10"/>
+          <p:cNvSpPr txBox="1"/>
+          <p:nvPr/>
+        </p:nvSpPr>
+        <p:spPr>
+          <a:xfrm>
+            <a:off x="1691640" y="4343400"/>
+            <a:ext cx="5394960" cy="274320"/>
+          </a:xfrm>
+          <a:prstGeom prst="rect">
+            <a:avLst/>
+          </a:prstGeom>
+          <a:noFill/>
+          <a:ln/>
+        </p:spPr>
+        <p:txBody>
+          <a:bodyPr wrap="square" lIns="0" tIns="0" rIns="0" bIns="0" rtlCol="0" anchor="t"/>
+          <a:lstStyle/>
+          <a:p>
             <a:pPr indent="0" marL="0">
-              <a:spcAft>
-                <a:spcPts val="400"/>
-              </a:spcAft>
               <a:buNone/>
             </a:pPr>
             <a:r>
@@ -2526,11 +2542,30 @@
             </a:r>
             <a:endParaRPr lang="en-US" sz="1150" dirty="0"/>
           </a:p>
+        </p:txBody>
+      </p:sp>
+      <p:sp>
+        <p:nvSpPr>
+          <p:cNvPr id="15" name="Text 11"/>
+          <p:cNvSpPr txBox="1"/>
+          <p:nvPr/>
+        </p:nvSpPr>
+        <p:spPr>
+          <a:xfrm>
+            <a:off x="777240" y="4672584"/>
+            <a:ext cx="914400" cy="274320"/>
+          </a:xfrm>
+          <a:prstGeom prst="rect">
+            <a:avLst/>
+          </a:prstGeom>
+          <a:noFill/>
+          <a:ln/>
+        </p:spPr>
+        <p:txBody>
+          <a:bodyPr wrap="square" lIns="0" tIns="0" rIns="0" bIns="0" rtlCol="0" anchor="t"/>
+          <a:lstStyle/>
           <a:p>
             <a:pPr indent="0" marL="0">
-              <a:spcAft>
-                <a:spcPts val="400"/>
-              </a:spcAft>
               <a:buNone/>
             </a:pPr>
             <a:r>
@@ -2539,12 +2574,34 @@
                   <a:schemeClr val="accent1"/>
                 </a:solidFill>
               </a:rPr>
-              <a:t>Team   </a:t>
-            </a:r>
+              <a:t>Team</a:t>
+            </a:r>
+            <a:endParaRPr lang="en-US" sz="1150" dirty="0"/>
+          </a:p>
+        </p:txBody>
+      </p:sp>
+      <p:sp>
+        <p:nvSpPr>
+          <p:cNvPr id="16" name="Text 12"/>
+          <p:cNvSpPr txBox="1"/>
+          <p:nvPr/>
+        </p:nvSpPr>
+        <p:spPr>
+          <a:xfrm>
+            <a:off x="1691640" y="4672584"/>
+            <a:ext cx="5394960" cy="274320"/>
+          </a:xfrm>
+          <a:prstGeom prst="rect">
+            <a:avLst/>
+          </a:prstGeom>
+          <a:noFill/>
+          <a:ln/>
+        </p:spPr>
+        <p:txBody>
+          <a:bodyPr wrap="square" lIns="0" tIns="0" rIns="0" bIns="0" rtlCol="0" anchor="t"/>
+          <a:lstStyle/>
+          <a:p>
             <a:pPr indent="0" marL="0">
-              <a:spcAft>
-                <a:spcPts val="400"/>
-              </a:spcAft>
               <a:buNone/>
             </a:pPr>
             <a:r>
@@ -2557,11 +2614,30 @@
             </a:r>
             <a:endParaRPr lang="en-US" sz="1150" dirty="0"/>
           </a:p>
+        </p:txBody>
+      </p:sp>
+      <p:sp>
+        <p:nvSpPr>
+          <p:cNvPr id="17" name="Text 13"/>
+          <p:cNvSpPr txBox="1"/>
+          <p:nvPr/>
+        </p:nvSpPr>
+        <p:spPr>
+          <a:xfrm>
+            <a:off x="777240" y="5001768"/>
+            <a:ext cx="914400" cy="274320"/>
+          </a:xfrm>
+          <a:prstGeom prst="rect">
+            <a:avLst/>
+          </a:prstGeom>
+          <a:noFill/>
+          <a:ln/>
+        </p:spPr>
+        <p:txBody>
+          <a:bodyPr wrap="square" lIns="0" tIns="0" rIns="0" bIns="0" rtlCol="0" anchor="t"/>
+          <a:lstStyle/>
           <a:p>
             <a:pPr indent="0" marL="0">
-              <a:spcAft>
-                <a:spcPts val="400"/>
-              </a:spcAft>
               <a:buNone/>
             </a:pPr>
             <a:r>
@@ -2570,12 +2646,34 @@
                   <a:schemeClr val="accent1"/>
                 </a:solidFill>
               </a:rPr>
-              <a:t>Members   </a:t>
-            </a:r>
+              <a:t>Members</a:t>
+            </a:r>
+            <a:endParaRPr lang="en-US" sz="1150" dirty="0"/>
+          </a:p>
+        </p:txBody>
+      </p:sp>
+      <p:sp>
+        <p:nvSpPr>
+          <p:cNvPr id="18" name="Text 14"/>
+          <p:cNvSpPr txBox="1"/>
+          <p:nvPr/>
+        </p:nvSpPr>
+        <p:spPr>
+          <a:xfrm>
+            <a:off x="1691640" y="5001768"/>
+            <a:ext cx="5394960" cy="274320"/>
+          </a:xfrm>
+          <a:prstGeom prst="rect">
+            <a:avLst/>
+          </a:prstGeom>
+          <a:noFill/>
+          <a:ln/>
+        </p:spPr>
+        <p:txBody>
+          <a:bodyPr wrap="square" lIns="0" tIns="0" rIns="0" bIns="0" rtlCol="0" anchor="t"/>
+          <a:lstStyle/>
+          <a:p>
             <a:pPr indent="0" marL="0">
-              <a:spcAft>
-                <a:spcPts val="400"/>
-              </a:spcAft>
               <a:buNone/>
             </a:pPr>
             <a:r>
@@ -2588,48 +2686,102 @@
             </a:r>
             <a:endParaRPr lang="en-US" sz="1150" dirty="0"/>
           </a:p>
+        </p:txBody>
+      </p:sp>
+      <p:sp>
+        <p:nvSpPr>
+          <p:cNvPr id="19" name="Text 15"/>
+          <p:cNvSpPr txBox="1"/>
+          <p:nvPr/>
+        </p:nvSpPr>
+        <p:spPr>
+          <a:xfrm>
+            <a:off x="1691640" y="5330952"/>
+            <a:ext cx="5394960" cy="274320"/>
+          </a:xfrm>
+          <a:prstGeom prst="rect">
+            <a:avLst/>
+          </a:prstGeom>
+          <a:noFill/>
+          <a:ln/>
+        </p:spPr>
+        <p:txBody>
+          <a:bodyPr wrap="square" lIns="0" tIns="0" rIns="0" bIns="0" rtlCol="0" anchor="t"/>
+          <a:lstStyle/>
           <a:p>
             <a:pPr indent="0" marL="0">
-              <a:spcAft>
-                <a:spcPts val="400"/>
-              </a:spcAft>
-              <a:buNone/>
-            </a:pPr>
+              <a:buNone/>
+            </a:pPr>
+            <a:r>
+              <a:rPr lang="en-US" sz="1150" dirty="0">
+                <a:solidFill>
+                  <a:schemeClr val="accent5"/>
+                </a:solidFill>
+              </a:rPr>
+              <a:t>Atharv Raj (1ms25ci025@msrit.edu)  ·  Harshil Jain (1ms25ci052@msrit.edu)</a:t>
+            </a:r>
+            <a:endParaRPr lang="en-US" sz="1150" dirty="0"/>
+          </a:p>
+        </p:txBody>
+      </p:sp>
+      <p:sp>
+        <p:nvSpPr>
+          <p:cNvPr id="20" name="Text 16"/>
+          <p:cNvSpPr txBox="1"/>
+          <p:nvPr/>
+        </p:nvSpPr>
+        <p:spPr>
+          <a:xfrm>
+            <a:off x="777240" y="5660136"/>
+            <a:ext cx="914400" cy="274320"/>
+          </a:xfrm>
+          <a:prstGeom prst="rect">
+            <a:avLst/>
+          </a:prstGeom>
+          <a:noFill/>
+          <a:ln/>
+        </p:spPr>
+        <p:txBody>
+          <a:bodyPr wrap="square" lIns="0" tIns="0" rIns="0" bIns="0" rtlCol="0" anchor="t"/>
+          <a:lstStyle/>
+          <a:p>
             <a:pPr indent="0" marL="0">
-              <a:spcAft>
-                <a:spcPts val="400"/>
-              </a:spcAft>
-              <a:buNone/>
-            </a:pPr>
-            <a:r>
-              <a:rPr lang="en-US" sz="1150" dirty="0">
-                <a:solidFill>
-                  <a:schemeClr val="accent5"/>
-                </a:solidFill>
-              </a:rPr>
-              <a:t>Atharv Raj (1ms25ci025@msrit.edu)  ·  Harshil Jain (1ms25ci052@msrit.edu)</a:t>
+              <a:buNone/>
+            </a:pPr>
+            <a:r>
+              <a:rPr lang="en-US" sz="1150" b="1" dirty="0">
+                <a:solidFill>
+                  <a:schemeClr val="accent1"/>
+                </a:solidFill>
+              </a:rPr>
+              <a:t>GitHub</a:t>
             </a:r>
             <a:endParaRPr lang="en-US" sz="1150" dirty="0"/>
           </a:p>
+        </p:txBody>
+      </p:sp>
+      <p:sp>
+        <p:nvSpPr>
+          <p:cNvPr id="21" name="Text 17"/>
+          <p:cNvSpPr txBox="1"/>
+          <p:nvPr/>
+        </p:nvSpPr>
+        <p:spPr>
+          <a:xfrm>
+            <a:off x="1691640" y="5660136"/>
+            <a:ext cx="5394960" cy="274320"/>
+          </a:xfrm>
+          <a:prstGeom prst="rect">
+            <a:avLst/>
+          </a:prstGeom>
+          <a:noFill/>
+          <a:ln/>
+        </p:spPr>
+        <p:txBody>
+          <a:bodyPr wrap="square" lIns="0" tIns="0" rIns="0" bIns="0" rtlCol="0" anchor="t"/>
+          <a:lstStyle/>
           <a:p>
             <a:pPr indent="0" marL="0">
-              <a:spcAft>
-                <a:spcPts val="400"/>
-              </a:spcAft>
-              <a:buNone/>
-            </a:pPr>
-            <a:r>
-              <a:rPr lang="en-US" sz="1150" b="1" dirty="0">
-                <a:solidFill>
-                  <a:schemeClr val="accent1"/>
-                </a:solidFill>
-              </a:rPr>
-              <a:t>GitHub   </a:t>
-            </a:r>
-            <a:pPr indent="0" marL="0">
-              <a:spcAft>
-                <a:spcPts val="400"/>
-              </a:spcAft>
               <a:buNone/>
             </a:pPr>
             <a:r>
@@ -3652,7 +3804,7 @@
       </p:sp>
       <p:sp>
         <p:nvSpPr>
-          <p:cNvPr id="25" name="Slide Number Placeholder 0"/>
+          <p:cNvPr id="34" name="Slide Number Placeholder 0"/>
           <p:cNvSpPr>
             <a:spLocks noGrp="1"/>
           </p:cNvSpPr>
@@ -5229,7 +5381,7 @@
       </p:sp>
       <p:sp>
         <p:nvSpPr>
-          <p:cNvPr id="25" name="Slide Number Placeholder 0"/>
+          <p:cNvPr id="51" name="Slide Number Placeholder 0"/>
           <p:cNvSpPr>
             <a:spLocks noGrp="1"/>
           </p:cNvSpPr>
@@ -6305,7 +6457,7 @@
       </p:sp>
       <p:sp>
         <p:nvSpPr>
-          <p:cNvPr id="25" name="Slide Number Placeholder 0"/>
+          <p:cNvPr id="27" name="Slide Number Placeholder 0"/>
           <p:cNvSpPr>
             <a:spLocks noGrp="1"/>
           </p:cNvSpPr>
@@ -7325,9 +7477,6 @@
               </a:rPr>
               <a:t>EchoFlow </a:t>
             </a:r>
-            <a:pPr indent="0" marL="0">
-              <a:buNone/>
-            </a:pPr>
             <a:r>
               <a:rPr lang="en-US" sz="1800" dirty="0">
                 <a:solidFill>
@@ -7342,7 +7491,7 @@
       </p:sp>
       <p:sp>
         <p:nvSpPr>
-          <p:cNvPr id="25" name="Slide Number Placeholder 0"/>
+          <p:cNvPr id="33" name="Slide Number Placeholder 0"/>
           <p:cNvSpPr>
             <a:spLocks noGrp="1"/>
           </p:cNvSpPr>
@@ -9258,7 +9407,7 @@
       </p:sp>
       <p:sp>
         <p:nvSpPr>
-          <p:cNvPr id="25" name="Slide Number Placeholder 0"/>
+          <p:cNvPr id="63" name="Slide Number Placeholder 0"/>
           <p:cNvSpPr>
             <a:spLocks noGrp="1"/>
           </p:cNvSpPr>
@@ -10315,9 +10464,6 @@
               </a:rPr>
               <a:t>Watch the full demo: </a:t>
             </a:r>
-            <a:pPr indent="0" marL="0">
-              <a:buNone/>
-            </a:pPr>
             <a:r>
               <a:rPr lang="en-US" sz="1200" b="1" u="sng" dirty="0">
                 <a:solidFill>
@@ -10339,7 +10485,7 @@
       </p:sp>
       <p:sp>
         <p:nvSpPr>
-          <p:cNvPr id="25" name="Slide Number Placeholder 0"/>
+          <p:cNvPr id="35" name="Slide Number Placeholder 0"/>
           <p:cNvSpPr>
             <a:spLocks noGrp="1"/>
           </p:cNvSpPr>
@@ -11797,7 +11943,7 @@
       </p:sp>
       <p:sp>
         <p:nvSpPr>
-          <p:cNvPr id="25" name="Slide Number Placeholder 0"/>
+          <p:cNvPr id="48" name="Slide Number Placeholder 0"/>
           <p:cNvSpPr>
             <a:spLocks noGrp="1"/>
           </p:cNvSpPr>
@@ -12073,9 +12219,6 @@
               </a:rPr>
               <a:t>1</a:t>
             </a:r>
-            <a:pPr indent="0" marL="0">
-              <a:buNone/>
-            </a:pPr>
             <a:r>
               <a:rPr lang="en-US" sz="1400" dirty="0">
                 <a:solidFill>
@@ -12690,7 +12833,7 @@
       </p:sp>
       <p:sp>
         <p:nvSpPr>
-          <p:cNvPr id="25" name="Slide Number Placeholder 0"/>
+          <p:cNvPr id="29" name="Slide Number Placeholder 0"/>
           <p:cNvSpPr>
             <a:spLocks noGrp="1"/>
           </p:cNvSpPr>
@@ -13606,7 +13749,7 @@
       </p:sp>
       <p:sp>
         <p:nvSpPr>
-          <p:cNvPr id="25" name="Slide Number Placeholder 0"/>
+          <p:cNvPr id="23" name="Slide Number Placeholder 0"/>
           <p:cNvSpPr>
             <a:spLocks noGrp="1"/>
           </p:cNvSpPr>
@@ -14718,7 +14861,7 @@
       </p:sp>
       <p:sp>
         <p:nvSpPr>
-          <p:cNvPr id="25" name="Slide Number Placeholder 0"/>
+          <p:cNvPr id="37" name="Slide Number Placeholder 0"/>
           <p:cNvSpPr>
             <a:spLocks noGrp="1"/>
           </p:cNvSpPr>

</xml_diff>